<commit_message>
fix(api): default PPTX templates fixed using generate_pptx_template script
</commit_message>
<xml_diff>
--- a/backend/app/templates/pptx/corporate.pptx
+++ b/backend/app/templates/pptx/corporate.pptx
@@ -4,7 +4,8 @@
   <p:sldMasterIdLst>
     <p:sldMasterId id="2147483648" r:id="rId1"/>
   </p:sldMasterIdLst>
-  <p:sldSz cx="12191695" cy="6858000" type="screen4x3"/>
+  <p:sldIdLst/>
+  <p:sldSz cx="12192000" cy="6858000" type="screen4x3"/>
   <p:notesSz cx="6858000" cy="9144000"/>
   <p:defaultTextStyle>
     <a:defPPr>
@@ -107,6 +108,14 @@
 <file path=ppt/slideLayouts/slideLayout1.xml><?xml version="1.0" encoding="utf-8"?>
 <p:sldLayout xmlns:a="http://schemas.openxmlformats.org/drawingml/2006/main" xmlns:r="http://schemas.openxmlformats.org/officeDocument/2006/relationships" xmlns:p="http://schemas.openxmlformats.org/presentationml/2006/main" type="title" preserve="1">
   <p:cSld name="Title Slide">
+    <p:bg>
+      <p:bgPr>
+        <a:solidFill>
+          <a:srgbClr val="0F2740"/>
+        </a:solidFill>
+        <a:effectLst/>
+      </p:bgPr>
+    </p:bg>
     <p:spTree>
       <p:nvGrpSpPr>
         <p:cNvPr id="1" name=""/>
@@ -123,331 +132,367 @@
       </p:grpSpPr>
       <p:sp>
         <p:nvSpPr>
-          <p:cNvPr id="102" name="Shape 102"/>
+          <p:cNvPr id="2" name="Title 1"/>
+          <p:cNvSpPr>
+            <a:spLocks noGrp="1"/>
+          </p:cNvSpPr>
+          <p:nvPr>
+            <p:ph type="ctrTitle"/>
+          </p:nvPr>
+        </p:nvSpPr>
+        <p:spPr>
+          <a:xfrm>
+            <a:off x="685800" y="2130425"/>
+            <a:ext cx="7772400" cy="1470025"/>
+          </a:xfrm>
+        </p:spPr>
+        <p:txBody>
+          <a:bodyPr/>
+          <a:lstStyle/>
+          <a:p>
+            <a:pPr>
+              <a:defRPr sz="4400" b="1">
+                <a:solidFill>
+                  <a:srgbClr val="FFFFFF"/>
+                </a:solidFill>
+              </a:defRPr>
+            </a:pPr>
+            <a:r>
+              <a:rPr lang="en-US" smtClean="0" sz="4400" b="1">
+                <a:solidFill>
+                  <a:srgbClr val="FFFFFF"/>
+                </a:solidFill>
+              </a:rPr>
+              <a:t>Click to edit Master title style</a:t>
+            </a:r>
+            <a:endParaRPr lang="en-US"/>
+          </a:p>
+        </p:txBody>
+      </p:sp>
+      <p:sp>
+        <p:nvSpPr>
+          <p:cNvPr id="3" name="Subtitle 2"/>
+          <p:cNvSpPr>
+            <a:spLocks noGrp="1"/>
+          </p:cNvSpPr>
+          <p:nvPr>
+            <p:ph type="subTitle" idx="1"/>
+          </p:nvPr>
+        </p:nvSpPr>
+        <p:spPr>
+          <a:xfrm>
+            <a:off x="1371600" y="3886200"/>
+            <a:ext cx="6400800" cy="1752600"/>
+          </a:xfrm>
+        </p:spPr>
+        <p:txBody>
+          <a:bodyPr/>
+          <a:lstStyle>
+            <a:lvl1pPr marL="0" indent="0" algn="ctr">
+              <a:buNone/>
+              <a:defRPr>
+                <a:solidFill>
+                  <a:schemeClr val="tx1">
+                    <a:tint val="75000"/>
+                  </a:schemeClr>
+                </a:solidFill>
+              </a:defRPr>
+            </a:lvl1pPr>
+            <a:lvl2pPr marL="457200" indent="0" algn="ctr">
+              <a:buNone/>
+              <a:defRPr>
+                <a:solidFill>
+                  <a:schemeClr val="tx1">
+                    <a:tint val="75000"/>
+                  </a:schemeClr>
+                </a:solidFill>
+              </a:defRPr>
+            </a:lvl2pPr>
+            <a:lvl3pPr marL="914400" indent="0" algn="ctr">
+              <a:buNone/>
+              <a:defRPr>
+                <a:solidFill>
+                  <a:schemeClr val="tx1">
+                    <a:tint val="75000"/>
+                  </a:schemeClr>
+                </a:solidFill>
+              </a:defRPr>
+            </a:lvl3pPr>
+            <a:lvl4pPr marL="1371600" indent="0" algn="ctr">
+              <a:buNone/>
+              <a:defRPr>
+                <a:solidFill>
+                  <a:schemeClr val="tx1">
+                    <a:tint val="75000"/>
+                  </a:schemeClr>
+                </a:solidFill>
+              </a:defRPr>
+            </a:lvl4pPr>
+            <a:lvl5pPr marL="1828800" indent="0" algn="ctr">
+              <a:buNone/>
+              <a:defRPr>
+                <a:solidFill>
+                  <a:schemeClr val="tx1">
+                    <a:tint val="75000"/>
+                  </a:schemeClr>
+                </a:solidFill>
+              </a:defRPr>
+            </a:lvl5pPr>
+            <a:lvl6pPr marL="2286000" indent="0" algn="ctr">
+              <a:buNone/>
+              <a:defRPr>
+                <a:solidFill>
+                  <a:schemeClr val="tx1">
+                    <a:tint val="75000"/>
+                  </a:schemeClr>
+                </a:solidFill>
+              </a:defRPr>
+            </a:lvl6pPr>
+            <a:lvl7pPr marL="2743200" indent="0" algn="ctr">
+              <a:buNone/>
+              <a:defRPr>
+                <a:solidFill>
+                  <a:schemeClr val="tx1">
+                    <a:tint val="75000"/>
+                  </a:schemeClr>
+                </a:solidFill>
+              </a:defRPr>
+            </a:lvl7pPr>
+            <a:lvl8pPr marL="3200400" indent="0" algn="ctr">
+              <a:buNone/>
+              <a:defRPr>
+                <a:solidFill>
+                  <a:schemeClr val="tx1">
+                    <a:tint val="75000"/>
+                  </a:schemeClr>
+                </a:solidFill>
+              </a:defRPr>
+            </a:lvl8pPr>
+            <a:lvl9pPr marL="3657600" indent="0" algn="ctr">
+              <a:buNone/>
+              <a:defRPr>
+                <a:solidFill>
+                  <a:schemeClr val="tx1">
+                    <a:tint val="75000"/>
+                  </a:schemeClr>
+                </a:solidFill>
+              </a:defRPr>
+            </a:lvl9pPr>
+          </a:lstStyle>
+          <a:p>
+            <a:pPr>
+              <a:defRPr sz="4400" b="1">
+                <a:solidFill>
+                  <a:srgbClr val="FFFFFF"/>
+                </a:solidFill>
+              </a:defRPr>
+            </a:pPr>
+            <a:r>
+              <a:rPr lang="en-US" smtClean="0" sz="4400" b="1">
+                <a:solidFill>
+                  <a:srgbClr val="FFFFFF"/>
+                </a:solidFill>
+              </a:rPr>
+              <a:t>Click to edit Master subtitle style</a:t>
+            </a:r>
+            <a:endParaRPr lang="en-US"/>
+          </a:p>
+        </p:txBody>
+      </p:sp>
+      <p:sp>
+        <p:nvSpPr>
+          <p:cNvPr id="4" name="Date Placeholder 3"/>
+          <p:cNvSpPr>
+            <a:spLocks noGrp="1"/>
+          </p:cNvSpPr>
+          <p:nvPr>
+            <p:ph type="dt" sz="half" idx="10"/>
+          </p:nvPr>
+        </p:nvSpPr>
+        <p:spPr/>
+        <p:txBody>
+          <a:bodyPr/>
+          <a:lstStyle/>
+          <a:p>
+            <a:fld id="{5BCAD085-E8A6-8845-BD4E-CB4CCA059FC4}" type="datetimeFigureOut">
+              <a:rPr lang="en-US" smtClean="0"/>
+              <a:t>1/27/13</a:t>
+            </a:fld>
+            <a:endParaRPr lang="en-US"/>
+          </a:p>
+        </p:txBody>
+      </p:sp>
+      <p:sp>
+        <p:nvSpPr>
+          <p:cNvPr id="5" name="Footer Placeholder 4"/>
+          <p:cNvSpPr>
+            <a:spLocks noGrp="1"/>
+          </p:cNvSpPr>
+          <p:nvPr>
+            <p:ph type="ftr" sz="quarter" idx="11"/>
+          </p:nvPr>
+        </p:nvSpPr>
+        <p:spPr/>
+        <p:txBody>
+          <a:bodyPr/>
+          <a:lstStyle/>
+          <a:p>
+            <a:endParaRPr lang="en-US"/>
+          </a:p>
+        </p:txBody>
+      </p:sp>
+      <p:sp>
+        <p:nvSpPr>
+          <p:cNvPr id="6" name="Slide Number Placeholder 5"/>
+          <p:cNvSpPr>
+            <a:spLocks noGrp="1"/>
+          </p:cNvSpPr>
+          <p:nvPr>
+            <p:ph type="sldNum" sz="quarter" idx="12"/>
+          </p:nvPr>
+        </p:nvSpPr>
+        <p:spPr/>
+        <p:txBody>
+          <a:bodyPr/>
+          <a:lstStyle/>
+          <a:p>
+            <a:fld id="{C1FF6DA9-008F-8B48-92A6-B652298478BF}" type="slidenum">
+              <a:rPr lang="en-US" smtClean="0"/>
+              <a:t>‹#›</a:t>
+            </a:fld>
+            <a:endParaRPr lang="en-US"/>
+          </a:p>
+        </p:txBody>
+      </p:sp>
+      <p:sp>
+        <p:nvSpPr>
+          <p:cNvPr id="7" name="Rectangle 3"/>
           <p:cNvSpPr/>
           <p:nvPr/>
         </p:nvSpPr>
         <p:spPr>
           <a:xfrm>
-            <a:off x="731520" y="914400"/>
-            <a:ext cx="1828800" cy="54864"/>
+            <a:off x="0" y="0"/>
+            <a:ext cx="256032" cy="6858000"/>
           </a:xfrm>
           <a:prstGeom prst="rect">
             <a:avLst/>
           </a:prstGeom>
           <a:solidFill>
-            <a:srgbClr val="3D8BFD"/>
+            <a:srgbClr val="F2A33C"/>
           </a:solidFill>
           <a:ln>
             <a:noFill/>
           </a:ln>
+          <a:effectLst/>
         </p:spPr>
         <p:style>
-          <a:lnRef idx="0"/>
-          <a:fillRef idx="0"/>
-          <a:effectRef idx="0"/>
+          <a:lnRef idx="1">
+            <a:schemeClr val="accent1"/>
+          </a:lnRef>
+          <a:fillRef idx="3">
+            <a:schemeClr val="accent1"/>
+          </a:fillRef>
+          <a:effectRef idx="2">
+            <a:schemeClr val="accent1"/>
+          </a:effectRef>
+          <a:fontRef idx="minor">
+            <a:schemeClr val="lt1"/>
+          </a:fontRef>
         </p:style>
         <p:txBody>
-          <a:bodyPr/>
-          <a:lstStyle/>
-          <a:p/>
-        </p:txBody>
-      </p:sp>
-      <p:sp>
-        <p:nvSpPr>
-          <p:cNvPr id="101" name="Shape 101"/>
+          <a:bodyPr rtlCol="0" anchor="ctr"/>
+          <a:lstStyle/>
+          <a:p>
+            <a:pPr algn="ctr"/>
+          </a:p>
+        </p:txBody>
+      </p:sp>
+      <p:sp>
+        <p:nvSpPr>
+          <p:cNvPr id="8" name="Oval 3"/>
           <p:cNvSpPr/>
           <p:nvPr/>
         </p:nvSpPr>
         <p:spPr>
           <a:xfrm>
-            <a:rot val="180"/>
-            <a:off x="9601200" y="5029200"/>
-            <a:ext cx="3200400" cy="2286000"/>
+            <a:off x="9509760" y="4206240"/>
+            <a:ext cx="3291840" cy="3291840"/>
           </a:xfrm>
-          <a:prstGeom prst="rtTriangle">
+          <a:prstGeom prst="ellipse">
             <a:avLst/>
           </a:prstGeom>
           <a:solidFill>
-            <a:srgbClr val="3D8BFD"/>
+            <a:srgbClr val="41423F"/>
           </a:solidFill>
           <a:ln>
             <a:noFill/>
           </a:ln>
+          <a:effectLst/>
         </p:spPr>
         <p:style>
-          <a:lnRef idx="0"/>
-          <a:fillRef idx="0"/>
-          <a:effectRef idx="0"/>
+          <a:lnRef idx="1">
+            <a:schemeClr val="accent1"/>
+          </a:lnRef>
+          <a:fillRef idx="3">
+            <a:schemeClr val="accent1"/>
+          </a:fillRef>
+          <a:effectRef idx="2">
+            <a:schemeClr val="accent1"/>
+          </a:effectRef>
+          <a:fontRef idx="minor">
+            <a:schemeClr val="lt1"/>
+          </a:fontRef>
         </p:style>
         <p:txBody>
-          <a:bodyPr/>
-          <a:lstStyle/>
-          <a:p/>
-        </p:txBody>
-      </p:sp>
-      <p:sp>
-        <p:nvSpPr>
-          <p:cNvPr id="100" name="Shape 100"/>
+          <a:bodyPr rtlCol="0" anchor="ctr"/>
+          <a:lstStyle/>
+          <a:p>
+            <a:pPr algn="ctr"/>
+          </a:p>
+        </p:txBody>
+      </p:sp>
+      <p:sp>
+        <p:nvSpPr>
+          <p:cNvPr id="9" name="Oval 3"/>
           <p:cNvSpPr/>
           <p:nvPr/>
         </p:nvSpPr>
         <p:spPr>
           <a:xfrm>
-            <a:rot val="180"/>
-            <a:off x="8686800" y="4114800"/>
-            <a:ext cx="4114800" cy="3200400"/>
+            <a:off x="10607040" y="3383280"/>
+            <a:ext cx="1371600" cy="1371600"/>
           </a:xfrm>
-          <a:prstGeom prst="rtTriangle">
+          <a:prstGeom prst="ellipse">
             <a:avLst/>
           </a:prstGeom>
           <a:solidFill>
-            <a:srgbClr val="1B4B82"/>
+            <a:srgbClr val="173552"/>
           </a:solidFill>
           <a:ln>
             <a:noFill/>
           </a:ln>
+          <a:effectLst/>
         </p:spPr>
         <p:style>
-          <a:lnRef idx="0"/>
-          <a:fillRef idx="0"/>
-          <a:effectRef idx="0"/>
+          <a:lnRef idx="1">
+            <a:schemeClr val="accent1"/>
+          </a:lnRef>
+          <a:fillRef idx="3">
+            <a:schemeClr val="accent1"/>
+          </a:fillRef>
+          <a:effectRef idx="2">
+            <a:schemeClr val="accent1"/>
+          </a:effectRef>
+          <a:fontRef idx="minor">
+            <a:schemeClr val="lt1"/>
+          </a:fontRef>
         </p:style>
         <p:txBody>
-          <a:bodyPr/>
-          <a:lstStyle/>
-          <a:p/>
-        </p:txBody>
-      </p:sp>
-      <p:sp>
-        <p:nvSpPr>
-          <p:cNvPr id="2" name="Title 1"/>
-          <p:cNvSpPr>
-            <a:spLocks noGrp="1"/>
-          </p:cNvSpPr>
-          <p:nvPr>
-            <p:ph type="ctrTitle"/>
-          </p:nvPr>
-        </p:nvSpPr>
-        <p:spPr>
-          <a:xfrm>
-            <a:off x="731520" y="1371600"/>
-            <a:ext cx="10515600" cy="1828800"/>
-          </a:xfrm>
-        </p:spPr>
-        <p:txBody>
-          <a:bodyPr wrap="square" anchor="t">
-            <a:normAutofit/>
-          </a:bodyPr>
-          <a:lstStyle/>
-          <a:p>
-            <a:pPr>
-              <a:defRPr sz="4400" b="1">
-                <a:solidFill>
-                  <a:srgbClr val="FFFFFF"/>
-                </a:solidFill>
-                <a:latin typeface="Calibri"/>
-              </a:defRPr>
-            </a:pPr>
-            <a:r>
-              <a:rPr lang="en-US" smtClean="0"/>
-              <a:t>Click to edit Master title style</a:t>
-            </a:r>
-            <a:endParaRPr lang="en-US"/>
-          </a:p>
-        </p:txBody>
-      </p:sp>
-      <p:sp>
-        <p:nvSpPr>
-          <p:cNvPr id="3" name="Subtitle 2"/>
-          <p:cNvSpPr>
-            <a:spLocks noGrp="1"/>
-          </p:cNvSpPr>
-          <p:nvPr>
-            <p:ph type="subTitle" idx="1"/>
-          </p:nvPr>
-        </p:nvSpPr>
-        <p:spPr>
-          <a:xfrm>
-            <a:off x="731520" y="3657600"/>
-            <a:ext cx="10515600" cy="1828800"/>
-          </a:xfrm>
-        </p:spPr>
-        <p:txBody>
-          <a:bodyPr wrap="square">
-            <a:normAutofit/>
-          </a:bodyPr>
-          <a:lstStyle>
-            <a:lvl1pPr marL="0" indent="0" algn="ctr">
-              <a:buNone/>
-              <a:defRPr>
-                <a:solidFill>
-                  <a:schemeClr val="tx1">
-                    <a:tint val="75000"/>
-                  </a:schemeClr>
-                </a:solidFill>
-              </a:defRPr>
-            </a:lvl1pPr>
-            <a:lvl2pPr marL="457200" indent="0" algn="ctr">
-              <a:buNone/>
-              <a:defRPr>
-                <a:solidFill>
-                  <a:schemeClr val="tx1">
-                    <a:tint val="75000"/>
-                  </a:schemeClr>
-                </a:solidFill>
-              </a:defRPr>
-            </a:lvl2pPr>
-            <a:lvl3pPr marL="914400" indent="0" algn="ctr">
-              <a:buNone/>
-              <a:defRPr>
-                <a:solidFill>
-                  <a:schemeClr val="tx1">
-                    <a:tint val="75000"/>
-                  </a:schemeClr>
-                </a:solidFill>
-              </a:defRPr>
-            </a:lvl3pPr>
-            <a:lvl4pPr marL="1371600" indent="0" algn="ctr">
-              <a:buNone/>
-              <a:defRPr>
-                <a:solidFill>
-                  <a:schemeClr val="tx1">
-                    <a:tint val="75000"/>
-                  </a:schemeClr>
-                </a:solidFill>
-              </a:defRPr>
-            </a:lvl4pPr>
-            <a:lvl5pPr marL="1828800" indent="0" algn="ctr">
-              <a:buNone/>
-              <a:defRPr>
-                <a:solidFill>
-                  <a:schemeClr val="tx1">
-                    <a:tint val="75000"/>
-                  </a:schemeClr>
-                </a:solidFill>
-              </a:defRPr>
-            </a:lvl5pPr>
-            <a:lvl6pPr marL="2286000" indent="0" algn="ctr">
-              <a:buNone/>
-              <a:defRPr>
-                <a:solidFill>
-                  <a:schemeClr val="tx1">
-                    <a:tint val="75000"/>
-                  </a:schemeClr>
-                </a:solidFill>
-              </a:defRPr>
-            </a:lvl6pPr>
-            <a:lvl7pPr marL="2743200" indent="0" algn="ctr">
-              <a:buNone/>
-              <a:defRPr>
-                <a:solidFill>
-                  <a:schemeClr val="tx1">
-                    <a:tint val="75000"/>
-                  </a:schemeClr>
-                </a:solidFill>
-              </a:defRPr>
-            </a:lvl7pPr>
-            <a:lvl8pPr marL="3200400" indent="0" algn="ctr">
-              <a:buNone/>
-              <a:defRPr>
-                <a:solidFill>
-                  <a:schemeClr val="tx1">
-                    <a:tint val="75000"/>
-                  </a:schemeClr>
-                </a:solidFill>
-              </a:defRPr>
-            </a:lvl8pPr>
-            <a:lvl9pPr marL="3657600" indent="0" algn="ctr">
-              <a:buNone/>
-              <a:defRPr>
-                <a:solidFill>
-                  <a:schemeClr val="tx1">
-                    <a:tint val="75000"/>
-                  </a:schemeClr>
-                </a:solidFill>
-              </a:defRPr>
-            </a:lvl9pPr>
-          </a:lstStyle>
-          <a:p>
-            <a:pPr>
-              <a:defRPr sz="2000" b="0">
-                <a:solidFill>
-                  <a:srgbClr val="8899BB"/>
-                </a:solidFill>
-                <a:latin typeface="Calibri"/>
-              </a:defRPr>
-            </a:pPr>
-            <a:r>
-              <a:rPr lang="en-US" smtClean="0"/>
-              <a:t>Click to edit Master subtitle style</a:t>
-            </a:r>
-            <a:endParaRPr lang="en-US"/>
-          </a:p>
-        </p:txBody>
-      </p:sp>
-      <p:sp>
-        <p:nvSpPr>
-          <p:cNvPr id="4" name="Date Placeholder 3"/>
-          <p:cNvSpPr>
-            <a:spLocks noGrp="1"/>
-          </p:cNvSpPr>
-          <p:nvPr>
-            <p:ph type="dt" sz="half" idx="10"/>
-          </p:nvPr>
-        </p:nvSpPr>
-        <p:spPr/>
-        <p:txBody>
-          <a:bodyPr/>
-          <a:lstStyle/>
-          <a:p>
-            <a:fld id="{5BCAD085-E8A6-8845-BD4E-CB4CCA059FC4}" type="datetimeFigureOut">
-              <a:rPr lang="en-US" smtClean="0"/>
-              <a:t>1/27/13</a:t>
-            </a:fld>
-            <a:endParaRPr lang="en-US"/>
-          </a:p>
-        </p:txBody>
-      </p:sp>
-      <p:sp>
-        <p:nvSpPr>
-          <p:cNvPr id="5" name="Footer Placeholder 4"/>
-          <p:cNvSpPr>
-            <a:spLocks noGrp="1"/>
-          </p:cNvSpPr>
-          <p:nvPr>
-            <p:ph type="ftr" sz="quarter" idx="11"/>
-          </p:nvPr>
-        </p:nvSpPr>
-        <p:spPr/>
-        <p:txBody>
-          <a:bodyPr/>
-          <a:lstStyle/>
-          <a:p>
-            <a:endParaRPr lang="en-US"/>
-          </a:p>
-        </p:txBody>
-      </p:sp>
-      <p:sp>
-        <p:nvSpPr>
-          <p:cNvPr id="6" name="Slide Number Placeholder 5"/>
-          <p:cNvSpPr>
-            <a:spLocks noGrp="1"/>
-          </p:cNvSpPr>
-          <p:nvPr>
-            <p:ph type="sldNum" sz="quarter" idx="12"/>
-          </p:nvPr>
-        </p:nvSpPr>
-        <p:spPr/>
-        <p:txBody>
-          <a:bodyPr/>
-          <a:lstStyle/>
-          <a:p>
-            <a:fld id="{C1FF6DA9-008F-8B48-92A6-B652298478BF}" type="slidenum">
-              <a:rPr lang="en-US" smtClean="0"/>
-              <a:t>‹#›</a:t>
-            </a:fld>
-            <a:endParaRPr lang="en-US"/>
+          <a:bodyPr rtlCol="0" anchor="ctr"/>
+          <a:lstStyle/>
+          <a:p>
+            <a:pPr algn="ctr"/>
           </a:p>
         </p:txBody>
       </p:sp>
@@ -457,13 +502,6 @@
         <p14:creationId xmlns:p14="http://schemas.microsoft.com/office/powerpoint/2010/main" val="3168075583"/>
       </p:ext>
     </p:extLst>
-    <p:bg>
-      <p:bgPr>
-        <a:solidFill>
-          <a:srgbClr val="0F2A4A"/>
-        </a:solidFill>
-      </p:bgPr>
-    </p:bg>
   </p:cSld>
   <p:clrMapOvr>
     <a:masterClrMapping/>
@@ -474,6 +512,14 @@
 <file path=ppt/slideLayouts/slideLayout10.xml><?xml version="1.0" encoding="utf-8"?>
 <p:sldLayout xmlns:a="http://schemas.openxmlformats.org/drawingml/2006/main" xmlns:r="http://schemas.openxmlformats.org/officeDocument/2006/relationships" xmlns:p="http://schemas.openxmlformats.org/presentationml/2006/main" type="vertTx" preserve="1">
   <p:cSld name="Title and Vertical Text">
+    <p:bg>
+      <p:bgPr>
+        <a:solidFill>
+          <a:srgbClr val="0F2740"/>
+        </a:solidFill>
+        <a:effectLst/>
+      </p:bgPr>
+    </p:bg>
     <p:spTree>
       <p:nvGrpSpPr>
         <p:cNvPr id="1" name=""/>
@@ -503,8 +549,19 @@
           <a:bodyPr/>
           <a:lstStyle/>
           <a:p>
-            <a:r>
-              <a:rPr lang="en-US" smtClean="0"/>
+            <a:pPr>
+              <a:defRPr sz="3200" b="1">
+                <a:solidFill>
+                  <a:srgbClr val="FFFFFF"/>
+                </a:solidFill>
+              </a:defRPr>
+            </a:pPr>
+            <a:r>
+              <a:rPr lang="en-US" smtClean="0" sz="3200" b="1">
+                <a:solidFill>
+                  <a:srgbClr val="FFFFFF"/>
+                </a:solidFill>
+              </a:rPr>
               <a:t>Click to edit Master title style</a:t>
             </a:r>
             <a:endParaRPr lang="en-US"/>
@@ -526,37 +583,87 @@
           <a:bodyPr vert="eaVert"/>
           <a:lstStyle/>
           <a:p>
-            <a:pPr lvl="0"/>
-            <a:r>
-              <a:rPr lang="en-US" smtClean="0"/>
+            <a:pPr lvl="0">
+              <a:defRPr sz="2000">
+                <a:solidFill>
+                  <a:srgbClr val="C7D3E2"/>
+                </a:solidFill>
+              </a:defRPr>
+            </a:pPr>
+            <a:r>
+              <a:rPr lang="en-US" smtClean="0" sz="2000" b="0">
+                <a:solidFill>
+                  <a:srgbClr val="C7D3E2"/>
+                </a:solidFill>
+              </a:rPr>
               <a:t>Click to edit Master text styles</a:t>
             </a:r>
           </a:p>
           <a:p>
-            <a:pPr lvl="1"/>
-            <a:r>
-              <a:rPr lang="en-US" smtClean="0"/>
+            <a:pPr lvl="1">
+              <a:defRPr sz="2000">
+                <a:solidFill>
+                  <a:srgbClr val="C7D3E2"/>
+                </a:solidFill>
+              </a:defRPr>
+            </a:pPr>
+            <a:r>
+              <a:rPr lang="en-US" smtClean="0" sz="2000" b="0">
+                <a:solidFill>
+                  <a:srgbClr val="C7D3E2"/>
+                </a:solidFill>
+              </a:rPr>
               <a:t>Second level</a:t>
             </a:r>
           </a:p>
           <a:p>
-            <a:pPr lvl="2"/>
-            <a:r>
-              <a:rPr lang="en-US" smtClean="0"/>
+            <a:pPr lvl="2">
+              <a:defRPr sz="2000">
+                <a:solidFill>
+                  <a:srgbClr val="C7D3E2"/>
+                </a:solidFill>
+              </a:defRPr>
+            </a:pPr>
+            <a:r>
+              <a:rPr lang="en-US" smtClean="0" sz="2000" b="0">
+                <a:solidFill>
+                  <a:srgbClr val="C7D3E2"/>
+                </a:solidFill>
+              </a:rPr>
               <a:t>Third level</a:t>
             </a:r>
           </a:p>
           <a:p>
-            <a:pPr lvl="3"/>
-            <a:r>
-              <a:rPr lang="en-US" smtClean="0"/>
+            <a:pPr lvl="3">
+              <a:defRPr sz="2000">
+                <a:solidFill>
+                  <a:srgbClr val="C7D3E2"/>
+                </a:solidFill>
+              </a:defRPr>
+            </a:pPr>
+            <a:r>
+              <a:rPr lang="en-US" smtClean="0" sz="2000" b="0">
+                <a:solidFill>
+                  <a:srgbClr val="C7D3E2"/>
+                </a:solidFill>
+              </a:rPr>
               <a:t>Fourth level</a:t>
             </a:r>
           </a:p>
           <a:p>
-            <a:pPr lvl="4"/>
-            <a:r>
-              <a:rPr lang="en-US" smtClean="0"/>
+            <a:pPr lvl="4">
+              <a:defRPr sz="2000">
+                <a:solidFill>
+                  <a:srgbClr val="C7D3E2"/>
+                </a:solidFill>
+              </a:defRPr>
+            </a:pPr>
+            <a:r>
+              <a:rPr lang="en-US" smtClean="0" sz="2000" b="0">
+                <a:solidFill>
+                  <a:srgbClr val="C7D3E2"/>
+                </a:solidFill>
+              </a:rPr>
               <a:t>Fifth level</a:t>
             </a:r>
             <a:endParaRPr lang="en-US"/>
@@ -644,6 +751,14 @@
 <file path=ppt/slideLayouts/slideLayout11.xml><?xml version="1.0" encoding="utf-8"?>
 <p:sldLayout xmlns:a="http://schemas.openxmlformats.org/drawingml/2006/main" xmlns:r="http://schemas.openxmlformats.org/officeDocument/2006/relationships" xmlns:p="http://schemas.openxmlformats.org/presentationml/2006/main" type="vertTitleAndTx" preserve="1">
   <p:cSld name="Vertical Title and Text">
+    <p:bg>
+      <p:bgPr>
+        <a:solidFill>
+          <a:srgbClr val="0F2740"/>
+        </a:solidFill>
+        <a:effectLst/>
+      </p:bgPr>
+    </p:bg>
     <p:spTree>
       <p:nvGrpSpPr>
         <p:cNvPr id="1" name=""/>
@@ -678,8 +793,19 @@
           <a:bodyPr vert="eaVert"/>
           <a:lstStyle/>
           <a:p>
-            <a:r>
-              <a:rPr lang="en-US" smtClean="0"/>
+            <a:pPr>
+              <a:defRPr sz="3200" b="1">
+                <a:solidFill>
+                  <a:srgbClr val="FFFFFF"/>
+                </a:solidFill>
+              </a:defRPr>
+            </a:pPr>
+            <a:r>
+              <a:rPr lang="en-US" smtClean="0" sz="3200" b="1">
+                <a:solidFill>
+                  <a:srgbClr val="FFFFFF"/>
+                </a:solidFill>
+              </a:rPr>
               <a:t>Click to edit Master title style</a:t>
             </a:r>
             <a:endParaRPr lang="en-US"/>
@@ -706,37 +832,87 @@
           <a:bodyPr vert="eaVert"/>
           <a:lstStyle/>
           <a:p>
-            <a:pPr lvl="0"/>
-            <a:r>
-              <a:rPr lang="en-US" smtClean="0"/>
+            <a:pPr lvl="0">
+              <a:defRPr sz="2000">
+                <a:solidFill>
+                  <a:srgbClr val="C7D3E2"/>
+                </a:solidFill>
+              </a:defRPr>
+            </a:pPr>
+            <a:r>
+              <a:rPr lang="en-US" smtClean="0" sz="2000" b="0">
+                <a:solidFill>
+                  <a:srgbClr val="C7D3E2"/>
+                </a:solidFill>
+              </a:rPr>
               <a:t>Click to edit Master text styles</a:t>
             </a:r>
           </a:p>
           <a:p>
-            <a:pPr lvl="1"/>
-            <a:r>
-              <a:rPr lang="en-US" smtClean="0"/>
+            <a:pPr lvl="1">
+              <a:defRPr sz="2000">
+                <a:solidFill>
+                  <a:srgbClr val="C7D3E2"/>
+                </a:solidFill>
+              </a:defRPr>
+            </a:pPr>
+            <a:r>
+              <a:rPr lang="en-US" smtClean="0" sz="2000" b="0">
+                <a:solidFill>
+                  <a:srgbClr val="C7D3E2"/>
+                </a:solidFill>
+              </a:rPr>
               <a:t>Second level</a:t>
             </a:r>
           </a:p>
           <a:p>
-            <a:pPr lvl="2"/>
-            <a:r>
-              <a:rPr lang="en-US" smtClean="0"/>
+            <a:pPr lvl="2">
+              <a:defRPr sz="2000">
+                <a:solidFill>
+                  <a:srgbClr val="C7D3E2"/>
+                </a:solidFill>
+              </a:defRPr>
+            </a:pPr>
+            <a:r>
+              <a:rPr lang="en-US" smtClean="0" sz="2000" b="0">
+                <a:solidFill>
+                  <a:srgbClr val="C7D3E2"/>
+                </a:solidFill>
+              </a:rPr>
               <a:t>Third level</a:t>
             </a:r>
           </a:p>
           <a:p>
-            <a:pPr lvl="3"/>
-            <a:r>
-              <a:rPr lang="en-US" smtClean="0"/>
+            <a:pPr lvl="3">
+              <a:defRPr sz="2000">
+                <a:solidFill>
+                  <a:srgbClr val="C7D3E2"/>
+                </a:solidFill>
+              </a:defRPr>
+            </a:pPr>
+            <a:r>
+              <a:rPr lang="en-US" smtClean="0" sz="2000" b="0">
+                <a:solidFill>
+                  <a:srgbClr val="C7D3E2"/>
+                </a:solidFill>
+              </a:rPr>
               <a:t>Fourth level</a:t>
             </a:r>
           </a:p>
           <a:p>
-            <a:pPr lvl="4"/>
-            <a:r>
-              <a:rPr lang="en-US" smtClean="0"/>
+            <a:pPr lvl="4">
+              <a:defRPr sz="2000">
+                <a:solidFill>
+                  <a:srgbClr val="C7D3E2"/>
+                </a:solidFill>
+              </a:defRPr>
+            </a:pPr>
+            <a:r>
+              <a:rPr lang="en-US" smtClean="0" sz="2000" b="0">
+                <a:solidFill>
+                  <a:srgbClr val="C7D3E2"/>
+                </a:solidFill>
+              </a:rPr>
               <a:t>Fifth level</a:t>
             </a:r>
             <a:endParaRPr lang="en-US"/>
@@ -824,6 +1000,14 @@
 <file path=ppt/slideLayouts/slideLayout2.xml><?xml version="1.0" encoding="utf-8"?>
 <p:sldLayout xmlns:a="http://schemas.openxmlformats.org/drawingml/2006/main" xmlns:r="http://schemas.openxmlformats.org/officeDocument/2006/relationships" xmlns:p="http://schemas.openxmlformats.org/presentationml/2006/main" type="obj" preserve="1">
   <p:cSld name="Title and Content">
+    <p:bg>
+      <p:bgPr>
+        <a:solidFill>
+          <a:srgbClr val="0F2740"/>
+        </a:solidFill>
+        <a:effectLst/>
+      </p:bgPr>
+    </p:bg>
     <p:spTree>
       <p:nvGrpSpPr>
         <p:cNvPr id="1" name=""/>
@@ -840,166 +1024,6 @@
       </p:grpSpPr>
       <p:sp>
         <p:nvSpPr>
-          <p:cNvPr id="107" name="Shape 107"/>
-          <p:cNvSpPr/>
-          <p:nvPr/>
-        </p:nvSpPr>
-        <p:spPr>
-          <a:xfrm>
-            <a:off x="11612880" y="137160"/>
-            <a:ext cx="274320" cy="274320"/>
-          </a:xfrm>
-          <a:prstGeom prst="rect">
-            <a:avLst/>
-          </a:prstGeom>
-          <a:solidFill>
-            <a:srgbClr val="6DAEFE"/>
-          </a:solidFill>
-          <a:ln>
-            <a:noFill/>
-          </a:ln>
-        </p:spPr>
-        <p:style>
-          <a:lnRef idx="0"/>
-          <a:fillRef idx="0"/>
-          <a:effectRef idx="0"/>
-        </p:style>
-        <p:txBody>
-          <a:bodyPr/>
-          <a:lstStyle/>
-          <a:p/>
-        </p:txBody>
-      </p:sp>
-      <p:sp>
-        <p:nvSpPr>
-          <p:cNvPr id="106" name="Shape 106"/>
-          <p:cNvSpPr/>
-          <p:nvPr/>
-        </p:nvSpPr>
-        <p:spPr>
-          <a:xfrm>
-            <a:off x="11338560" y="274320"/>
-            <a:ext cx="457200" cy="457200"/>
-          </a:xfrm>
-          <a:prstGeom prst="rect">
-            <a:avLst/>
-          </a:prstGeom>
-          <a:solidFill>
-            <a:srgbClr val="3D8BFD"/>
-          </a:solidFill>
-          <a:ln>
-            <a:noFill/>
-          </a:ln>
-        </p:spPr>
-        <p:style>
-          <a:lnRef idx="0"/>
-          <a:fillRef idx="0"/>
-          <a:effectRef idx="0"/>
-        </p:style>
-        <p:txBody>
-          <a:bodyPr/>
-          <a:lstStyle/>
-          <a:p/>
-        </p:txBody>
-      </p:sp>
-      <p:sp>
-        <p:nvSpPr>
-          <p:cNvPr id="105" name="Shape 105"/>
-          <p:cNvSpPr/>
-          <p:nvPr/>
-        </p:nvSpPr>
-        <p:spPr>
-          <a:xfrm>
-            <a:off x="0" y="1051560"/>
-            <a:ext cx="12191695" cy="45720"/>
-          </a:xfrm>
-          <a:prstGeom prst="rect">
-            <a:avLst/>
-          </a:prstGeom>
-          <a:solidFill>
-            <a:srgbClr val="3D8BFD"/>
-          </a:solidFill>
-          <a:ln>
-            <a:noFill/>
-          </a:ln>
-        </p:spPr>
-        <p:style>
-          <a:lnRef idx="0"/>
-          <a:fillRef idx="0"/>
-          <a:effectRef idx="0"/>
-        </p:style>
-        <p:txBody>
-          <a:bodyPr/>
-          <a:lstStyle/>
-          <a:p/>
-        </p:txBody>
-      </p:sp>
-      <p:sp>
-        <p:nvSpPr>
-          <p:cNvPr id="104" name="Shape 104"/>
-          <p:cNvSpPr/>
-          <p:nvPr/>
-        </p:nvSpPr>
-        <p:spPr>
-          <a:xfrm>
-            <a:off x="0" y="0"/>
-            <a:ext cx="12191695" cy="1051560"/>
-          </a:xfrm>
-          <a:prstGeom prst="rect">
-            <a:avLst/>
-          </a:prstGeom>
-          <a:solidFill>
-            <a:srgbClr val="0F2A4A"/>
-          </a:solidFill>
-          <a:ln>
-            <a:noFill/>
-          </a:ln>
-        </p:spPr>
-        <p:style>
-          <a:lnRef idx="0"/>
-          <a:fillRef idx="0"/>
-          <a:effectRef idx="0"/>
-        </p:style>
-        <p:txBody>
-          <a:bodyPr/>
-          <a:lstStyle/>
-          <a:p/>
-        </p:txBody>
-      </p:sp>
-      <p:sp>
-        <p:nvSpPr>
-          <p:cNvPr id="103" name="Shape 103"/>
-          <p:cNvSpPr/>
-          <p:nvPr/>
-        </p:nvSpPr>
-        <p:spPr>
-          <a:xfrm>
-            <a:off x="0" y="0"/>
-            <a:ext cx="109728" cy="6858000"/>
-          </a:xfrm>
-          <a:prstGeom prst="rect">
-            <a:avLst/>
-          </a:prstGeom>
-          <a:solidFill>
-            <a:srgbClr val="0F2A4A"/>
-          </a:solidFill>
-          <a:ln>
-            <a:noFill/>
-          </a:ln>
-        </p:spPr>
-        <p:style>
-          <a:lnRef idx="0"/>
-          <a:fillRef idx="0"/>
-          <a:effectRef idx="0"/>
-        </p:style>
-        <p:txBody>
-          <a:bodyPr/>
-          <a:lstStyle/>
-          <a:p/>
-        </p:txBody>
-      </p:sp>
-      <p:sp>
-        <p:nvSpPr>
           <p:cNvPr id="2" name="Title 1"/>
           <p:cNvSpPr>
             <a:spLocks noGrp="1"/>
@@ -1008,28 +1032,24 @@
             <p:ph type="title"/>
           </p:nvPr>
         </p:nvSpPr>
-        <p:spPr>
-          <a:xfrm>
-            <a:off x="457200" y="137160"/>
-            <a:ext cx="10515600" cy="822960"/>
-          </a:xfrm>
-        </p:spPr>
-        <p:txBody>
-          <a:bodyPr wrap="square" anchor="ctr">
-            <a:normAutofit/>
-          </a:bodyPr>
+        <p:spPr/>
+        <p:txBody>
+          <a:bodyPr/>
           <a:lstStyle/>
           <a:p>
             <a:pPr>
-              <a:defRPr sz="2800" b="1">
+              <a:defRPr sz="3200" b="1">
                 <a:solidFill>
                   <a:srgbClr val="FFFFFF"/>
                 </a:solidFill>
-                <a:latin typeface="Calibri"/>
               </a:defRPr>
             </a:pPr>
             <a:r>
-              <a:rPr lang="en-US" smtClean="0"/>
+              <a:rPr lang="en-US" smtClean="0" sz="3200" b="1">
+                <a:solidFill>
+                  <a:srgbClr val="FFFFFF"/>
+                </a:solidFill>
+              </a:rPr>
               <a:t>Click to edit Master title style</a:t>
             </a:r>
             <a:endParaRPr lang="en-US"/>
@@ -1046,56 +1066,92 @@
             <p:ph idx="1"/>
           </p:nvPr>
         </p:nvSpPr>
-        <p:spPr>
-          <a:xfrm>
-            <a:off x="731520" y="1371600"/>
-            <a:ext cx="10515600" cy="5029200"/>
-          </a:xfrm>
-        </p:spPr>
-        <p:txBody>
-          <a:bodyPr wrap="square" anchor="t">
-            <a:noAutofit/>
-          </a:bodyPr>
+        <p:spPr/>
+        <p:txBody>
+          <a:bodyPr/>
           <a:lstStyle/>
           <a:p>
             <a:pPr lvl="0">
-              <a:defRPr sz="1800" b="0">
-                <a:solidFill>
-                  <a:srgbClr val="333333"/>
-                </a:solidFill>
-                <a:latin typeface="Calibri"/>
+              <a:defRPr sz="2000">
+                <a:solidFill>
+                  <a:srgbClr val="C7D3E2"/>
+                </a:solidFill>
               </a:defRPr>
             </a:pPr>
             <a:r>
-              <a:rPr lang="en-US" smtClean="0"/>
+              <a:rPr lang="en-US" smtClean="0" sz="2000" b="0">
+                <a:solidFill>
+                  <a:srgbClr val="C7D3E2"/>
+                </a:solidFill>
+              </a:rPr>
               <a:t>Click to edit Master text styles</a:t>
             </a:r>
           </a:p>
           <a:p>
-            <a:pPr lvl="1"/>
-            <a:r>
-              <a:rPr lang="en-US" smtClean="0"/>
+            <a:pPr lvl="1">
+              <a:defRPr sz="2000">
+                <a:solidFill>
+                  <a:srgbClr val="C7D3E2"/>
+                </a:solidFill>
+              </a:defRPr>
+            </a:pPr>
+            <a:r>
+              <a:rPr lang="en-US" smtClean="0" sz="2000" b="0">
+                <a:solidFill>
+                  <a:srgbClr val="C7D3E2"/>
+                </a:solidFill>
+              </a:rPr>
               <a:t>Second level</a:t>
             </a:r>
           </a:p>
           <a:p>
-            <a:pPr lvl="2"/>
-            <a:r>
-              <a:rPr lang="en-US" smtClean="0"/>
+            <a:pPr lvl="2">
+              <a:defRPr sz="2000">
+                <a:solidFill>
+                  <a:srgbClr val="C7D3E2"/>
+                </a:solidFill>
+              </a:defRPr>
+            </a:pPr>
+            <a:r>
+              <a:rPr lang="en-US" smtClean="0" sz="2000" b="0">
+                <a:solidFill>
+                  <a:srgbClr val="C7D3E2"/>
+                </a:solidFill>
+              </a:rPr>
               <a:t>Third level</a:t>
             </a:r>
           </a:p>
           <a:p>
-            <a:pPr lvl="3"/>
-            <a:r>
-              <a:rPr lang="en-US" smtClean="0"/>
+            <a:pPr lvl="3">
+              <a:defRPr sz="2000">
+                <a:solidFill>
+                  <a:srgbClr val="C7D3E2"/>
+                </a:solidFill>
+              </a:defRPr>
+            </a:pPr>
+            <a:r>
+              <a:rPr lang="en-US" smtClean="0" sz="2000" b="0">
+                <a:solidFill>
+                  <a:srgbClr val="C7D3E2"/>
+                </a:solidFill>
+              </a:rPr>
               <a:t>Fourth level</a:t>
             </a:r>
           </a:p>
           <a:p>
-            <a:pPr lvl="4"/>
-            <a:r>
-              <a:rPr lang="en-US" smtClean="0"/>
+            <a:pPr lvl="4">
+              <a:defRPr sz="2000">
+                <a:solidFill>
+                  <a:srgbClr val="C7D3E2"/>
+                </a:solidFill>
+              </a:defRPr>
+            </a:pPr>
+            <a:r>
+              <a:rPr lang="en-US" smtClean="0" sz="2000" b="0">
+                <a:solidFill>
+                  <a:srgbClr val="C7D3E2"/>
+                </a:solidFill>
+              </a:rPr>
               <a:t>Fifth level</a:t>
             </a:r>
             <a:endParaRPr lang="en-US"/>
@@ -1173,13 +1229,6 @@
         <p14:creationId xmlns:p14="http://schemas.microsoft.com/office/powerpoint/2010/main" val="2614314258"/>
       </p:ext>
     </p:extLst>
-    <p:bg>
-      <p:bgPr>
-        <a:solidFill>
-          <a:srgbClr val="FFFFFF"/>
-        </a:solidFill>
-      </p:bgPr>
-    </p:bg>
   </p:cSld>
   <p:clrMapOvr>
     <a:masterClrMapping/>
@@ -1190,6 +1239,14 @@
 <file path=ppt/slideLayouts/slideLayout3.xml><?xml version="1.0" encoding="utf-8"?>
 <p:sldLayout xmlns:a="http://schemas.openxmlformats.org/drawingml/2006/main" xmlns:r="http://schemas.openxmlformats.org/officeDocument/2006/relationships" xmlns:p="http://schemas.openxmlformats.org/presentationml/2006/main" type="secHead" preserve="1">
   <p:cSld name="Section Header">
+    <p:bg>
+      <p:bgPr>
+        <a:solidFill>
+          <a:srgbClr val="0F2740"/>
+        </a:solidFill>
+        <a:effectLst/>
+      </p:bgPr>
+    </p:bg>
     <p:spTree>
       <p:nvGrpSpPr>
         <p:cNvPr id="1" name=""/>
@@ -1228,8 +1285,19 @@
             </a:lvl1pPr>
           </a:lstStyle>
           <a:p>
-            <a:r>
-              <a:rPr lang="en-US" smtClean="0"/>
+            <a:pPr>
+              <a:defRPr sz="3200" b="1">
+                <a:solidFill>
+                  <a:srgbClr val="FFFFFF"/>
+                </a:solidFill>
+              </a:defRPr>
+            </a:pPr>
+            <a:r>
+              <a:rPr lang="en-US" smtClean="0" sz="3200" b="1">
+                <a:solidFill>
+                  <a:srgbClr val="FFFFFF"/>
+                </a:solidFill>
+              </a:rPr>
               <a:t>Click to edit Master title style</a:t>
             </a:r>
             <a:endParaRPr lang="en-US"/>
@@ -1347,9 +1415,19 @@
             </a:lvl9pPr>
           </a:lstStyle>
           <a:p>
-            <a:pPr lvl="0"/>
-            <a:r>
-              <a:rPr lang="en-US" smtClean="0"/>
+            <a:pPr lvl="0">
+              <a:defRPr sz="2000">
+                <a:solidFill>
+                  <a:srgbClr val="C7D3E2"/>
+                </a:solidFill>
+              </a:defRPr>
+            </a:pPr>
+            <a:r>
+              <a:rPr lang="en-US" smtClean="0" sz="2000" b="0">
+                <a:solidFill>
+                  <a:srgbClr val="C7D3E2"/>
+                </a:solidFill>
+              </a:rPr>
               <a:t>Click to edit Master text styles</a:t>
             </a:r>
           </a:p>
@@ -1436,6 +1514,14 @@
 <file path=ppt/slideLayouts/slideLayout4.xml><?xml version="1.0" encoding="utf-8"?>
 <p:sldLayout xmlns:a="http://schemas.openxmlformats.org/drawingml/2006/main" xmlns:r="http://schemas.openxmlformats.org/officeDocument/2006/relationships" xmlns:p="http://schemas.openxmlformats.org/presentationml/2006/main" type="twoObj" preserve="1">
   <p:cSld name="Two Content">
+    <p:bg>
+      <p:bgPr>
+        <a:solidFill>
+          <a:srgbClr val="0F2740"/>
+        </a:solidFill>
+        <a:effectLst/>
+      </p:bgPr>
+    </p:bg>
     <p:spTree>
       <p:nvGrpSpPr>
         <p:cNvPr id="1" name=""/>
@@ -1465,8 +1551,19 @@
           <a:bodyPr/>
           <a:lstStyle/>
           <a:p>
-            <a:r>
-              <a:rPr lang="en-US" smtClean="0"/>
+            <a:pPr>
+              <a:defRPr sz="3200" b="1">
+                <a:solidFill>
+                  <a:srgbClr val="FFFFFF"/>
+                </a:solidFill>
+              </a:defRPr>
+            </a:pPr>
+            <a:r>
+              <a:rPr lang="en-US" smtClean="0" sz="3200" b="1">
+                <a:solidFill>
+                  <a:srgbClr val="FFFFFF"/>
+                </a:solidFill>
+              </a:rPr>
               <a:t>Click to edit Master title style</a:t>
             </a:r>
             <a:endParaRPr lang="en-US"/>
@@ -1521,37 +1618,87 @@
             </a:lvl9pPr>
           </a:lstStyle>
           <a:p>
-            <a:pPr lvl="0"/>
-            <a:r>
-              <a:rPr lang="en-US" smtClean="0"/>
+            <a:pPr lvl="0">
+              <a:defRPr sz="2000">
+                <a:solidFill>
+                  <a:srgbClr val="C7D3E2"/>
+                </a:solidFill>
+              </a:defRPr>
+            </a:pPr>
+            <a:r>
+              <a:rPr lang="en-US" smtClean="0" sz="2000" b="0">
+                <a:solidFill>
+                  <a:srgbClr val="C7D3E2"/>
+                </a:solidFill>
+              </a:rPr>
               <a:t>Click to edit Master text styles</a:t>
             </a:r>
           </a:p>
           <a:p>
-            <a:pPr lvl="1"/>
-            <a:r>
-              <a:rPr lang="en-US" smtClean="0"/>
+            <a:pPr lvl="1">
+              <a:defRPr sz="2000">
+                <a:solidFill>
+                  <a:srgbClr val="C7D3E2"/>
+                </a:solidFill>
+              </a:defRPr>
+            </a:pPr>
+            <a:r>
+              <a:rPr lang="en-US" smtClean="0" sz="2000" b="0">
+                <a:solidFill>
+                  <a:srgbClr val="C7D3E2"/>
+                </a:solidFill>
+              </a:rPr>
               <a:t>Second level</a:t>
             </a:r>
           </a:p>
           <a:p>
-            <a:pPr lvl="2"/>
-            <a:r>
-              <a:rPr lang="en-US" smtClean="0"/>
+            <a:pPr lvl="2">
+              <a:defRPr sz="2000">
+                <a:solidFill>
+                  <a:srgbClr val="C7D3E2"/>
+                </a:solidFill>
+              </a:defRPr>
+            </a:pPr>
+            <a:r>
+              <a:rPr lang="en-US" smtClean="0" sz="2000" b="0">
+                <a:solidFill>
+                  <a:srgbClr val="C7D3E2"/>
+                </a:solidFill>
+              </a:rPr>
               <a:t>Third level</a:t>
             </a:r>
           </a:p>
           <a:p>
-            <a:pPr lvl="3"/>
-            <a:r>
-              <a:rPr lang="en-US" smtClean="0"/>
+            <a:pPr lvl="3">
+              <a:defRPr sz="2000">
+                <a:solidFill>
+                  <a:srgbClr val="C7D3E2"/>
+                </a:solidFill>
+              </a:defRPr>
+            </a:pPr>
+            <a:r>
+              <a:rPr lang="en-US" smtClean="0" sz="2000" b="0">
+                <a:solidFill>
+                  <a:srgbClr val="C7D3E2"/>
+                </a:solidFill>
+              </a:rPr>
               <a:t>Fourth level</a:t>
             </a:r>
           </a:p>
           <a:p>
-            <a:pPr lvl="4"/>
-            <a:r>
-              <a:rPr lang="en-US" smtClean="0"/>
+            <a:pPr lvl="4">
+              <a:defRPr sz="2000">
+                <a:solidFill>
+                  <a:srgbClr val="C7D3E2"/>
+                </a:solidFill>
+              </a:defRPr>
+            </a:pPr>
+            <a:r>
+              <a:rPr lang="en-US" smtClean="0" sz="2000" b="0">
+                <a:solidFill>
+                  <a:srgbClr val="C7D3E2"/>
+                </a:solidFill>
+              </a:rPr>
               <a:t>Fifth level</a:t>
             </a:r>
             <a:endParaRPr lang="en-US"/>
@@ -1724,6 +1871,14 @@
 <file path=ppt/slideLayouts/slideLayout5.xml><?xml version="1.0" encoding="utf-8"?>
 <p:sldLayout xmlns:a="http://schemas.openxmlformats.org/drawingml/2006/main" xmlns:r="http://schemas.openxmlformats.org/officeDocument/2006/relationships" xmlns:p="http://schemas.openxmlformats.org/presentationml/2006/main" type="twoTxTwoObj" preserve="1">
   <p:cSld name="Comparison">
+    <p:bg>
+      <p:bgPr>
+        <a:solidFill>
+          <a:srgbClr val="0F2740"/>
+        </a:solidFill>
+        <a:effectLst/>
+      </p:bgPr>
+    </p:bg>
     <p:spTree>
       <p:nvGrpSpPr>
         <p:cNvPr id="1" name=""/>
@@ -1757,8 +1912,19 @@
             </a:lvl1pPr>
           </a:lstStyle>
           <a:p>
-            <a:r>
-              <a:rPr lang="en-US" smtClean="0"/>
+            <a:pPr>
+              <a:defRPr sz="3200" b="1">
+                <a:solidFill>
+                  <a:srgbClr val="FFFFFF"/>
+                </a:solidFill>
+              </a:defRPr>
+            </a:pPr>
+            <a:r>
+              <a:rPr lang="en-US" smtClean="0" sz="3200" b="1">
+                <a:solidFill>
+                  <a:srgbClr val="FFFFFF"/>
+                </a:solidFill>
+              </a:rPr>
               <a:t>Click to edit Master title style</a:t>
             </a:r>
             <a:endParaRPr lang="en-US"/>
@@ -1822,9 +1988,19 @@
             </a:lvl9pPr>
           </a:lstStyle>
           <a:p>
-            <a:pPr lvl="0"/>
-            <a:r>
-              <a:rPr lang="en-US" smtClean="0"/>
+            <a:pPr lvl="0">
+              <a:defRPr sz="2000">
+                <a:solidFill>
+                  <a:srgbClr val="C7D3E2"/>
+                </a:solidFill>
+              </a:defRPr>
+            </a:pPr>
+            <a:r>
+              <a:rPr lang="en-US" smtClean="0" sz="2000" b="0">
+                <a:solidFill>
+                  <a:srgbClr val="C7D3E2"/>
+                </a:solidFill>
+              </a:rPr>
               <a:t>Click to edit Master text styles</a:t>
             </a:r>
           </a:p>
@@ -1972,9 +2148,19 @@
             </a:lvl9pPr>
           </a:lstStyle>
           <a:p>
-            <a:pPr lvl="0"/>
-            <a:r>
-              <a:rPr lang="en-US" smtClean="0"/>
+            <a:pPr lvl="0">
+              <a:defRPr sz="2000">
+                <a:solidFill>
+                  <a:srgbClr val="C7D3E2"/>
+                </a:solidFill>
+              </a:defRPr>
+            </a:pPr>
+            <a:r>
+              <a:rPr lang="en-US" smtClean="0" sz="2000" b="0">
+                <a:solidFill>
+                  <a:srgbClr val="C7D3E2"/>
+                </a:solidFill>
+              </a:rPr>
               <a:t>Click to edit Master text styles</a:t>
             </a:r>
           </a:p>
@@ -2146,6 +2332,14 @@
 <file path=ppt/slideLayouts/slideLayout6.xml><?xml version="1.0" encoding="utf-8"?>
 <p:sldLayout xmlns:a="http://schemas.openxmlformats.org/drawingml/2006/main" xmlns:r="http://schemas.openxmlformats.org/officeDocument/2006/relationships" xmlns:p="http://schemas.openxmlformats.org/presentationml/2006/main" type="titleOnly" preserve="1">
   <p:cSld name="Title Only">
+    <p:bg>
+      <p:bgPr>
+        <a:solidFill>
+          <a:srgbClr val="0F2740"/>
+        </a:solidFill>
+        <a:effectLst/>
+      </p:bgPr>
+    </p:bg>
     <p:spTree>
       <p:nvGrpSpPr>
         <p:cNvPr id="1" name=""/>
@@ -2162,134 +2356,6 @@
       </p:grpSpPr>
       <p:sp>
         <p:nvSpPr>
-          <p:cNvPr id="111" name="Shape 111"/>
-          <p:cNvSpPr/>
-          <p:nvPr/>
-        </p:nvSpPr>
-        <p:spPr>
-          <a:xfrm>
-            <a:off x="10058400" y="5029200"/>
-            <a:ext cx="1828800" cy="1828800"/>
-          </a:xfrm>
-          <a:prstGeom prst="ellipse">
-            <a:avLst/>
-          </a:prstGeom>
-          <a:solidFill>
-            <a:srgbClr val="6DAEFE"/>
-          </a:solidFill>
-          <a:ln>
-            <a:noFill/>
-          </a:ln>
-        </p:spPr>
-        <p:style>
-          <a:lnRef idx="0"/>
-          <a:fillRef idx="0"/>
-          <a:effectRef idx="0"/>
-        </p:style>
-        <p:txBody>
-          <a:bodyPr/>
-          <a:lstStyle/>
-          <a:p/>
-        </p:txBody>
-      </p:sp>
-      <p:sp>
-        <p:nvSpPr>
-          <p:cNvPr id="110" name="Shape 110"/>
-          <p:cNvSpPr/>
-          <p:nvPr/>
-        </p:nvSpPr>
-        <p:spPr>
-          <a:xfrm>
-            <a:off x="0" y="1051560"/>
-            <a:ext cx="12191695" cy="45720"/>
-          </a:xfrm>
-          <a:prstGeom prst="rect">
-            <a:avLst/>
-          </a:prstGeom>
-          <a:solidFill>
-            <a:srgbClr val="3D8BFD"/>
-          </a:solidFill>
-          <a:ln>
-            <a:noFill/>
-          </a:ln>
-        </p:spPr>
-        <p:style>
-          <a:lnRef idx="0"/>
-          <a:fillRef idx="0"/>
-          <a:effectRef idx="0"/>
-        </p:style>
-        <p:txBody>
-          <a:bodyPr/>
-          <a:lstStyle/>
-          <a:p/>
-        </p:txBody>
-      </p:sp>
-      <p:sp>
-        <p:nvSpPr>
-          <p:cNvPr id="109" name="Shape 109"/>
-          <p:cNvSpPr/>
-          <p:nvPr/>
-        </p:nvSpPr>
-        <p:spPr>
-          <a:xfrm>
-            <a:off x="0" y="0"/>
-            <a:ext cx="12191695" cy="1051560"/>
-          </a:xfrm>
-          <a:prstGeom prst="rect">
-            <a:avLst/>
-          </a:prstGeom>
-          <a:solidFill>
-            <a:srgbClr val="0F2A4A"/>
-          </a:solidFill>
-          <a:ln>
-            <a:noFill/>
-          </a:ln>
-        </p:spPr>
-        <p:style>
-          <a:lnRef idx="0"/>
-          <a:fillRef idx="0"/>
-          <a:effectRef idx="0"/>
-        </p:style>
-        <p:txBody>
-          <a:bodyPr/>
-          <a:lstStyle/>
-          <a:p/>
-        </p:txBody>
-      </p:sp>
-      <p:sp>
-        <p:nvSpPr>
-          <p:cNvPr id="108" name="Shape 108"/>
-          <p:cNvSpPr/>
-          <p:nvPr/>
-        </p:nvSpPr>
-        <p:spPr>
-          <a:xfrm>
-            <a:off x="0" y="0"/>
-            <a:ext cx="109728" cy="6858000"/>
-          </a:xfrm>
-          <a:prstGeom prst="rect">
-            <a:avLst/>
-          </a:prstGeom>
-          <a:solidFill>
-            <a:srgbClr val="0F2A4A"/>
-          </a:solidFill>
-          <a:ln>
-            <a:noFill/>
-          </a:ln>
-        </p:spPr>
-        <p:style>
-          <a:lnRef idx="0"/>
-          <a:fillRef idx="0"/>
-          <a:effectRef idx="0"/>
-        </p:style>
-        <p:txBody>
-          <a:bodyPr/>
-          <a:lstStyle/>
-          <a:p/>
-        </p:txBody>
-      </p:sp>
-      <p:sp>
-        <p:nvSpPr>
           <p:cNvPr id="2" name="Title 1"/>
           <p:cNvSpPr>
             <a:spLocks noGrp="1"/>
@@ -2298,16 +2364,9 @@
             <p:ph type="title"/>
           </p:nvPr>
         </p:nvSpPr>
-        <p:spPr>
-          <a:xfrm>
-            <a:off x="457200" y="137160"/>
-            <a:ext cx="10515600" cy="822960"/>
-          </a:xfrm>
-        </p:spPr>
-        <p:txBody>
-          <a:bodyPr wrap="square" anchor="ctr">
-            <a:normAutofit/>
-          </a:bodyPr>
+        <p:spPr/>
+        <p:txBody>
+          <a:bodyPr/>
           <a:lstStyle/>
           <a:p>
             <a:pPr>
@@ -2315,11 +2374,14 @@
                 <a:solidFill>
                   <a:srgbClr val="FFFFFF"/>
                 </a:solidFill>
-                <a:latin typeface="Calibri"/>
               </a:defRPr>
             </a:pPr>
             <a:r>
-              <a:rPr lang="en-US" smtClean="0"/>
+              <a:rPr lang="en-US" smtClean="0" sz="3200" b="1">
+                <a:solidFill>
+                  <a:srgbClr val="FFFFFF"/>
+                </a:solidFill>
+              </a:rPr>
               <a:t>Click to edit Master title style</a:t>
             </a:r>
             <a:endParaRPr lang="en-US"/>
@@ -2397,13 +2459,6 @@
         <p14:creationId xmlns:p14="http://schemas.microsoft.com/office/powerpoint/2010/main" val="727027711"/>
       </p:ext>
     </p:extLst>
-    <p:bg>
-      <p:bgPr>
-        <a:solidFill>
-          <a:srgbClr val="FFFFFF"/>
-        </a:solidFill>
-      </p:bgPr>
-    </p:bg>
   </p:cSld>
   <p:clrMapOvr>
     <a:masterClrMapping/>
@@ -2414,6 +2469,14 @@
 <file path=ppt/slideLayouts/slideLayout7.xml><?xml version="1.0" encoding="utf-8"?>
 <p:sldLayout xmlns:a="http://schemas.openxmlformats.org/drawingml/2006/main" xmlns:r="http://schemas.openxmlformats.org/officeDocument/2006/relationships" xmlns:p="http://schemas.openxmlformats.org/presentationml/2006/main" type="blank" preserve="1">
   <p:cSld name="Blank">
+    <p:bg>
+      <p:bgPr>
+        <a:solidFill>
+          <a:srgbClr val="0F2740"/>
+        </a:solidFill>
+        <a:effectLst/>
+      </p:bgPr>
+    </p:bg>
     <p:spTree>
       <p:nvGrpSpPr>
         <p:cNvPr id="1" name=""/>
@@ -2430,135 +2493,6 @@
       </p:grpSpPr>
       <p:sp>
         <p:nvSpPr>
-          <p:cNvPr id="115" name="Shape 115"/>
-          <p:cNvSpPr/>
-          <p:nvPr/>
-        </p:nvSpPr>
-        <p:spPr>
-          <a:xfrm>
-            <a:off x="731520" y="3383280"/>
-            <a:ext cx="274320" cy="274320"/>
-          </a:xfrm>
-          <a:prstGeom prst="rect">
-            <a:avLst/>
-          </a:prstGeom>
-          <a:solidFill>
-            <a:srgbClr val="6DAEFE"/>
-          </a:solidFill>
-          <a:ln>
-            <a:noFill/>
-          </a:ln>
-        </p:spPr>
-        <p:style>
-          <a:lnRef idx="0"/>
-          <a:fillRef idx="0"/>
-          <a:effectRef idx="0"/>
-        </p:style>
-        <p:txBody>
-          <a:bodyPr/>
-          <a:lstStyle/>
-          <a:p/>
-        </p:txBody>
-      </p:sp>
-      <p:sp>
-        <p:nvSpPr>
-          <p:cNvPr id="114" name="Shape 114"/>
-          <p:cNvSpPr/>
-          <p:nvPr/>
-        </p:nvSpPr>
-        <p:spPr>
-          <a:xfrm>
-            <a:off x="731520" y="3200400"/>
-            <a:ext cx="2286000" cy="54864"/>
-          </a:xfrm>
-          <a:prstGeom prst="rect">
-            <a:avLst/>
-          </a:prstGeom>
-          <a:solidFill>
-            <a:srgbClr val="3D8BFD"/>
-          </a:solidFill>
-          <a:ln>
-            <a:noFill/>
-          </a:ln>
-        </p:spPr>
-        <p:style>
-          <a:lnRef idx="0"/>
-          <a:fillRef idx="0"/>
-          <a:effectRef idx="0"/>
-        </p:style>
-        <p:txBody>
-          <a:bodyPr/>
-          <a:lstStyle/>
-          <a:p/>
-        </p:txBody>
-      </p:sp>
-      <p:sp>
-        <p:nvSpPr>
-          <p:cNvPr id="113" name="Shape 113"/>
-          <p:cNvSpPr/>
-          <p:nvPr/>
-        </p:nvSpPr>
-        <p:spPr>
-          <a:xfrm>
-            <a:rot val="270"/>
-            <a:off x="6400800" y="0"/>
-            <a:ext cx="2743200" cy="2743200"/>
-          </a:xfrm>
-          <a:prstGeom prst="rtTriangle">
-            <a:avLst/>
-          </a:prstGeom>
-          <a:solidFill>
-            <a:srgbClr val="3D8BFD"/>
-          </a:solidFill>
-          <a:ln>
-            <a:noFill/>
-          </a:ln>
-        </p:spPr>
-        <p:style>
-          <a:lnRef idx="0"/>
-          <a:fillRef idx="0"/>
-          <a:effectRef idx="0"/>
-        </p:style>
-        <p:txBody>
-          <a:bodyPr/>
-          <a:lstStyle/>
-          <a:p/>
-        </p:txBody>
-      </p:sp>
-      <p:sp>
-        <p:nvSpPr>
-          <p:cNvPr id="112" name="Shape 112"/>
-          <p:cNvSpPr/>
-          <p:nvPr/>
-        </p:nvSpPr>
-        <p:spPr>
-          <a:xfrm>
-            <a:off x="7315200" y="0"/>
-            <a:ext cx="5029200" cy="6858000"/>
-          </a:xfrm>
-          <a:prstGeom prst="rect">
-            <a:avLst/>
-          </a:prstGeom>
-          <a:solidFill>
-            <a:srgbClr val="1B4B82"/>
-          </a:solidFill>
-          <a:ln>
-            <a:noFill/>
-          </a:ln>
-        </p:spPr>
-        <p:style>
-          <a:lnRef idx="0"/>
-          <a:fillRef idx="0"/>
-          <a:effectRef idx="0"/>
-        </p:style>
-        <p:txBody>
-          <a:bodyPr/>
-          <a:lstStyle/>
-          <a:p/>
-        </p:txBody>
-      </p:sp>
-      <p:sp>
-        <p:nvSpPr>
           <p:cNvPr id="2" name="Date Placeholder 1"/>
           <p:cNvSpPr>
             <a:spLocks noGrp="1"/>
@@ -2628,13 +2562,6 @@
         <p14:creationId xmlns:p14="http://schemas.microsoft.com/office/powerpoint/2010/main" val="1212999818"/>
       </p:ext>
     </p:extLst>
-    <p:bg>
-      <p:bgPr>
-        <a:solidFill>
-          <a:srgbClr val="0F2A4A"/>
-        </a:solidFill>
-      </p:bgPr>
-    </p:bg>
   </p:cSld>
   <p:clrMapOvr>
     <a:masterClrMapping/>
@@ -2645,6 +2572,14 @@
 <file path=ppt/slideLayouts/slideLayout8.xml><?xml version="1.0" encoding="utf-8"?>
 <p:sldLayout xmlns:a="http://schemas.openxmlformats.org/drawingml/2006/main" xmlns:r="http://schemas.openxmlformats.org/officeDocument/2006/relationships" xmlns:p="http://schemas.openxmlformats.org/presentationml/2006/main" type="objTx" preserve="1">
   <p:cSld name="Content with Caption">
+    <p:bg>
+      <p:bgPr>
+        <a:solidFill>
+          <a:srgbClr val="0F2740"/>
+        </a:solidFill>
+        <a:effectLst/>
+      </p:bgPr>
+    </p:bg>
     <p:spTree>
       <p:nvGrpSpPr>
         <p:cNvPr id="1" name=""/>
@@ -2683,8 +2618,19 @@
             </a:lvl1pPr>
           </a:lstStyle>
           <a:p>
-            <a:r>
-              <a:rPr lang="en-US" smtClean="0"/>
+            <a:pPr>
+              <a:defRPr sz="3200" b="1">
+                <a:solidFill>
+                  <a:srgbClr val="FFFFFF"/>
+                </a:solidFill>
+              </a:defRPr>
+            </a:pPr>
+            <a:r>
+              <a:rPr lang="en-US" smtClean="0" sz="3200" b="1">
+                <a:solidFill>
+                  <a:srgbClr val="FFFFFF"/>
+                </a:solidFill>
+              </a:rPr>
               <a:t>Click to edit Master title style</a:t>
             </a:r>
             <a:endParaRPr lang="en-US"/>
@@ -2739,37 +2685,87 @@
             </a:lvl9pPr>
           </a:lstStyle>
           <a:p>
-            <a:pPr lvl="0"/>
-            <a:r>
-              <a:rPr lang="en-US" smtClean="0"/>
+            <a:pPr lvl="0">
+              <a:defRPr sz="2000">
+                <a:solidFill>
+                  <a:srgbClr val="C7D3E2"/>
+                </a:solidFill>
+              </a:defRPr>
+            </a:pPr>
+            <a:r>
+              <a:rPr lang="en-US" smtClean="0" sz="2000" b="0">
+                <a:solidFill>
+                  <a:srgbClr val="C7D3E2"/>
+                </a:solidFill>
+              </a:rPr>
               <a:t>Click to edit Master text styles</a:t>
             </a:r>
           </a:p>
           <a:p>
-            <a:pPr lvl="1"/>
-            <a:r>
-              <a:rPr lang="en-US" smtClean="0"/>
+            <a:pPr lvl="1">
+              <a:defRPr sz="2000">
+                <a:solidFill>
+                  <a:srgbClr val="C7D3E2"/>
+                </a:solidFill>
+              </a:defRPr>
+            </a:pPr>
+            <a:r>
+              <a:rPr lang="en-US" smtClean="0" sz="2000" b="0">
+                <a:solidFill>
+                  <a:srgbClr val="C7D3E2"/>
+                </a:solidFill>
+              </a:rPr>
               <a:t>Second level</a:t>
             </a:r>
           </a:p>
           <a:p>
-            <a:pPr lvl="2"/>
-            <a:r>
-              <a:rPr lang="en-US" smtClean="0"/>
+            <a:pPr lvl="2">
+              <a:defRPr sz="2000">
+                <a:solidFill>
+                  <a:srgbClr val="C7D3E2"/>
+                </a:solidFill>
+              </a:defRPr>
+            </a:pPr>
+            <a:r>
+              <a:rPr lang="en-US" smtClean="0" sz="2000" b="0">
+                <a:solidFill>
+                  <a:srgbClr val="C7D3E2"/>
+                </a:solidFill>
+              </a:rPr>
               <a:t>Third level</a:t>
             </a:r>
           </a:p>
           <a:p>
-            <a:pPr lvl="3"/>
-            <a:r>
-              <a:rPr lang="en-US" smtClean="0"/>
+            <a:pPr lvl="3">
+              <a:defRPr sz="2000">
+                <a:solidFill>
+                  <a:srgbClr val="C7D3E2"/>
+                </a:solidFill>
+              </a:defRPr>
+            </a:pPr>
+            <a:r>
+              <a:rPr lang="en-US" smtClean="0" sz="2000" b="0">
+                <a:solidFill>
+                  <a:srgbClr val="C7D3E2"/>
+                </a:solidFill>
+              </a:rPr>
               <a:t>Fourth level</a:t>
             </a:r>
           </a:p>
           <a:p>
-            <a:pPr lvl="4"/>
-            <a:r>
-              <a:rPr lang="en-US" smtClean="0"/>
+            <a:pPr lvl="4">
+              <a:defRPr sz="2000">
+                <a:solidFill>
+                  <a:srgbClr val="C7D3E2"/>
+                </a:solidFill>
+              </a:defRPr>
+            </a:pPr>
+            <a:r>
+              <a:rPr lang="en-US" smtClean="0" sz="2000" b="0">
+                <a:solidFill>
+                  <a:srgbClr val="C7D3E2"/>
+                </a:solidFill>
+              </a:rPr>
               <a:t>Fifth level</a:t>
             </a:r>
             <a:endParaRPr lang="en-US"/>
@@ -2833,9 +2829,19 @@
             </a:lvl9pPr>
           </a:lstStyle>
           <a:p>
-            <a:pPr lvl="0"/>
-            <a:r>
-              <a:rPr lang="en-US" smtClean="0"/>
+            <a:pPr lvl="0">
+              <a:defRPr sz="2000">
+                <a:solidFill>
+                  <a:srgbClr val="C7D3E2"/>
+                </a:solidFill>
+              </a:defRPr>
+            </a:pPr>
+            <a:r>
+              <a:rPr lang="en-US" smtClean="0" sz="2000" b="0">
+                <a:solidFill>
+                  <a:srgbClr val="C7D3E2"/>
+                </a:solidFill>
+              </a:rPr>
               <a:t>Click to edit Master text styles</a:t>
             </a:r>
           </a:p>
@@ -2922,6 +2928,14 @@
 <file path=ppt/slideLayouts/slideLayout9.xml><?xml version="1.0" encoding="utf-8"?>
 <p:sldLayout xmlns:a="http://schemas.openxmlformats.org/drawingml/2006/main" xmlns:r="http://schemas.openxmlformats.org/officeDocument/2006/relationships" xmlns:p="http://schemas.openxmlformats.org/presentationml/2006/main" type="picTx" preserve="1">
   <p:cSld name="Picture with Caption">
+    <p:bg>
+      <p:bgPr>
+        <a:solidFill>
+          <a:srgbClr val="0F2740"/>
+        </a:solidFill>
+        <a:effectLst/>
+      </p:bgPr>
+    </p:bg>
     <p:spTree>
       <p:nvGrpSpPr>
         <p:cNvPr id="1" name=""/>
@@ -2960,8 +2974,19 @@
             </a:lvl1pPr>
           </a:lstStyle>
           <a:p>
-            <a:r>
-              <a:rPr lang="en-US" smtClean="0"/>
+            <a:pPr>
+              <a:defRPr sz="3200" b="1">
+                <a:solidFill>
+                  <a:srgbClr val="FFFFFF"/>
+                </a:solidFill>
+              </a:defRPr>
+            </a:pPr>
+            <a:r>
+              <a:rPr lang="en-US" smtClean="0" sz="3200" b="1">
+                <a:solidFill>
+                  <a:srgbClr val="FFFFFF"/>
+                </a:solidFill>
+              </a:rPr>
               <a:t>Click to edit Master title style</a:t>
             </a:r>
             <a:endParaRPr lang="en-US"/>
@@ -3025,6 +3050,13 @@
             </a:lvl9pPr>
           </a:lstStyle>
           <a:p>
+            <a:pPr>
+              <a:defRPr sz="2000">
+                <a:solidFill>
+                  <a:srgbClr val="C7D3E2"/>
+                </a:solidFill>
+              </a:defRPr>
+            </a:pPr>
             <a:endParaRPr lang="en-US"/>
           </a:p>
         </p:txBody>
@@ -3086,9 +3118,19 @@
             </a:lvl9pPr>
           </a:lstStyle>
           <a:p>
-            <a:pPr lvl="0"/>
-            <a:r>
-              <a:rPr lang="en-US" smtClean="0"/>
+            <a:pPr lvl="0">
+              <a:defRPr sz="2000">
+                <a:solidFill>
+                  <a:srgbClr val="C7D3E2"/>
+                </a:solidFill>
+              </a:defRPr>
+            </a:pPr>
+            <a:r>
+              <a:rPr lang="en-US" smtClean="0" sz="2000" b="0">
+                <a:solidFill>
+                  <a:srgbClr val="C7D3E2"/>
+                </a:solidFill>
+              </a:rPr>
               <a:t>Click to edit Master text styles</a:t>
             </a:r>
           </a:p>
@@ -3176,9 +3218,12 @@
 <p:sldMaster xmlns:a="http://schemas.openxmlformats.org/drawingml/2006/main" xmlns:r="http://schemas.openxmlformats.org/officeDocument/2006/relationships" xmlns:p="http://schemas.openxmlformats.org/presentationml/2006/main">
   <p:cSld>
     <p:bg>
-      <p:bgRef idx="1001">
-        <a:schemeClr val="bg1"/>
-      </p:bgRef>
+      <p:bgPr>
+        <a:solidFill>
+          <a:srgbClr val="0F2740"/>
+        </a:solidFill>
+        <a:effectLst/>
+      </p:bgPr>
     </p:bg>
     <p:spTree>
       <p:nvGrpSpPr>
@@ -3682,45 +3727,201 @@
 </p:sldMaster>
 </file>
 
+<file path=ppt/slides/slide1.xml><?xml version="1.0" encoding="utf-8"?>
+<p:sld xmlns:a="http://schemas.openxmlformats.org/drawingml/2006/main" xmlns:p="http://schemas.openxmlformats.org/presentationml/2006/main" xmlns:r="http://schemas.openxmlformats.org/officeDocument/2006/relationships">
+  <p:cSld>
+    <p:spTree>
+      <p:nvGrpSpPr>
+        <p:cNvPr id="1" name=""/>
+        <p:cNvGrpSpPr/>
+        <p:nvPr/>
+      </p:nvGrpSpPr>
+      <p:grpSpPr/>
+      <p:sp>
+        <p:nvSpPr>
+          <p:cNvPr id="2" name="Title 1"/>
+          <p:cNvSpPr>
+            <a:spLocks noGrp="1"/>
+          </p:cNvSpPr>
+          <p:nvPr>
+            <p:ph type="ctrTitle"/>
+          </p:nvPr>
+        </p:nvSpPr>
+        <p:spPr/>
+        <p:txBody>
+          <a:bodyPr/>
+          <a:lstStyle/>
+          <a:p/>
+        </p:txBody>
+      </p:sp>
+      <p:sp>
+        <p:nvSpPr>
+          <p:cNvPr id="3" name="Subtitle 2"/>
+          <p:cNvSpPr>
+            <a:spLocks noGrp="1"/>
+          </p:cNvSpPr>
+          <p:nvPr>
+            <p:ph type="subTitle" idx="1"/>
+          </p:nvPr>
+        </p:nvSpPr>
+        <p:spPr/>
+        <p:txBody>
+          <a:bodyPr/>
+          <a:lstStyle/>
+          <a:p/>
+        </p:txBody>
+      </p:sp>
+    </p:spTree>
+  </p:cSld>
+  <p:clrMapOvr>
+    <a:masterClrMapping/>
+  </p:clrMapOvr>
+</p:sld>
+</file>
+
+<file path=ppt/slides/slide1.xml><?xml version="1.0" encoding="utf-8"?>
+<p:sld xmlns:a="http://schemas.openxmlformats.org/drawingml/2006/main" xmlns:p="http://schemas.openxmlformats.org/presentationml/2006/main" xmlns:r="http://schemas.openxmlformats.org/officeDocument/2006/relationships">
+  <p:cSld>
+    <p:spTree>
+      <p:nvGrpSpPr>
+        <p:cNvPr id="1" name=""/>
+        <p:cNvGrpSpPr/>
+        <p:nvPr/>
+      </p:nvGrpSpPr>
+      <p:grpSpPr/>
+      <p:sp>
+        <p:nvSpPr>
+          <p:cNvPr id="2" name="Title 1"/>
+          <p:cNvSpPr>
+            <a:spLocks noGrp="1"/>
+          </p:cNvSpPr>
+          <p:nvPr>
+            <p:ph type="ctrTitle"/>
+          </p:nvPr>
+        </p:nvSpPr>
+        <p:spPr/>
+        <p:txBody>
+          <a:bodyPr/>
+          <a:lstStyle/>
+          <a:p/>
+        </p:txBody>
+      </p:sp>
+      <p:sp>
+        <p:nvSpPr>
+          <p:cNvPr id="3" name="Subtitle 2"/>
+          <p:cNvSpPr>
+            <a:spLocks noGrp="1"/>
+          </p:cNvSpPr>
+          <p:nvPr>
+            <p:ph type="subTitle" idx="1"/>
+          </p:nvPr>
+        </p:nvSpPr>
+        <p:spPr/>
+        <p:txBody>
+          <a:bodyPr/>
+          <a:lstStyle/>
+          <a:p/>
+        </p:txBody>
+      </p:sp>
+    </p:spTree>
+  </p:cSld>
+  <p:clrMapOvr>
+    <a:masterClrMapping/>
+  </p:clrMapOvr>
+</p:sld>
+</file>
+
+<file path=ppt/slides/slide1.xml><?xml version="1.0" encoding="utf-8"?>
+<p:sld xmlns:a="http://schemas.openxmlformats.org/drawingml/2006/main" xmlns:p="http://schemas.openxmlformats.org/presentationml/2006/main" xmlns:r="http://schemas.openxmlformats.org/officeDocument/2006/relationships">
+  <p:cSld>
+    <p:spTree>
+      <p:nvGrpSpPr>
+        <p:cNvPr id="1" name=""/>
+        <p:cNvGrpSpPr/>
+        <p:nvPr/>
+      </p:nvGrpSpPr>
+      <p:grpSpPr/>
+      <p:sp>
+        <p:nvSpPr>
+          <p:cNvPr id="2" name="Title 1"/>
+          <p:cNvSpPr>
+            <a:spLocks noGrp="1"/>
+          </p:cNvSpPr>
+          <p:nvPr>
+            <p:ph type="ctrTitle"/>
+          </p:nvPr>
+        </p:nvSpPr>
+        <p:spPr/>
+        <p:txBody>
+          <a:bodyPr/>
+          <a:lstStyle/>
+          <a:p/>
+        </p:txBody>
+      </p:sp>
+      <p:sp>
+        <p:nvSpPr>
+          <p:cNvPr id="3" name="Subtitle 2"/>
+          <p:cNvSpPr>
+            <a:spLocks noGrp="1"/>
+          </p:cNvSpPr>
+          <p:nvPr>
+            <p:ph type="subTitle" idx="1"/>
+          </p:nvPr>
+        </p:nvSpPr>
+        <p:spPr/>
+        <p:txBody>
+          <a:bodyPr/>
+          <a:lstStyle/>
+          <a:p/>
+        </p:txBody>
+      </p:sp>
+    </p:spTree>
+  </p:cSld>
+  <p:clrMapOvr>
+    <a:masterClrMapping/>
+  </p:clrMapOvr>
+</p:sld>
+</file>
+
 <file path=ppt/theme/theme1.xml><?xml version="1.0" encoding="utf-8"?>
 <a:theme xmlns:a="http://schemas.openxmlformats.org/drawingml/2006/main" name="Office Theme">
   <a:themeElements>
     <a:clrScheme name="Office">
       <a:dk1>
-        <a:sysClr val="windowText" lastClr="000000"/>
+        <a:srgbClr val="000000"/>
       </a:dk1>
       <a:lt1>
-        <a:sysClr val="window" lastClr="FFFFFF"/>
+        <a:srgbClr val="FFFFFF"/>
       </a:lt1>
       <a:dk2>
-        <a:srgbClr val="1F497D"/>
+        <a:srgbClr val="DBDFE2"/>
       </a:dk2>
       <a:lt2>
-        <a:srgbClr val="EEECE1"/>
+        <a:srgbClr val="B5C2D2"/>
       </a:lt2>
       <a:accent1>
-        <a:srgbClr val="4F81BD"/>
+        <a:srgbClr val="F2A33C"/>
       </a:accent1>
       <a:accent2>
-        <a:srgbClr val="C0504D"/>
+        <a:srgbClr val="3E7CB1"/>
       </a:accent2>
       <a:accent3>
-        <a:srgbClr val="9BBB59"/>
+        <a:srgbClr val="356B9A"/>
       </a:accent3>
       <a:accent4>
-        <a:srgbClr val="8064A2"/>
+        <a:srgbClr val="F9D6A7"/>
       </a:accent4>
       <a:accent5>
-        <a:srgbClr val="4BACC6"/>
+        <a:srgbClr val="8C6B3E"/>
       </a:accent5>
       <a:accent6>
-        <a:srgbClr val="F79646"/>
+        <a:srgbClr val="9EBED8"/>
       </a:accent6>
       <a:hlink>
-        <a:srgbClr val="0000FF"/>
+        <a:srgbClr val="F2A33C"/>
       </a:hlink>
       <a:folHlink>
-        <a:srgbClr val="800080"/>
+        <a:srgbClr val="3E7CB1"/>
       </a:folHlink>
     </a:clrScheme>
     <a:fontScheme name="Office">

</xml_diff>